<commit_message>
fix: warn when a chart/SmartArt part parses but yields no text
Adversarial review found a rule-3 silent drop: charts and diagrams whose part
parsed successfully but produced empty text were skipped with no warning, unlike
every other graphicFrame branch. Emit the standard 'has no extractable text'
warning. The missing-chart fixture now also carries a valid-but-empty chart to
pin this path.

Co-Authored-By: Claude Fable 5 <noreply@anthropic.com>
</commit_message>
<xml_diff>
--- a/testdata/pptx/missing-chart.pptx
+++ b/testdata/pptx/missing-chart.pptx
@@ -6,6 +6,16 @@
   </p:sldIdLst>
   <p:sldSz cx="9144000" cy="6858000"/>
 </p:presentation>
+</file>
+
+<file path=ppt/charts/empty.xml><?xml version="1.0" encoding="utf-8"?>
+<c:chartSpace xmlns:a="http://schemas.openxmlformats.org/drawingml/2006/main" xmlns:c="http://schemas.openxmlformats.org/drawingml/2006/chart">
+  <c:chart>
+    <c:plotArea>
+      <c:barChart/>
+    </c:plotArea>
+  </c:chart>
+</c:chartSpace>
 </file>
 
 <file path=ppt/slideLayouts/slideLayout1.xml><?xml version="1.0" encoding="utf-8"?>
@@ -139,6 +149,22 @@
           </a:graphicData>
         </a:graphic>
       </p:graphicFrame>
+      <p:graphicFrame>
+        <p:nvGraphicFramePr>
+          <p:cNvPr id="4" name="Empty chart"/>
+          <p:cNvGraphicFramePr/>
+          <p:nvPr/>
+        </p:nvGraphicFramePr>
+        <p:xfrm>
+          <a:off x="4572000" y="914400"/>
+          <a:ext cx="3657600" cy="1828800"/>
+        </p:xfrm>
+        <a:graphic>
+          <a:graphicData xmlns:c="http://schemas.openxmlformats.org/drawingml/2006/chart" uri="http://schemas.openxmlformats.org/drawingml/2006/chart">
+            <c:chart r:id="rIdEmptyChart"/>
+          </a:graphicData>
+        </a:graphic>
+      </p:graphicFrame>
       <p:sp>
         <p:nvSpPr>
           <p:cNvPr id="3" name="Survivor"/>

</xml_diff>